<commit_message>
WIP: scripts y datos ampliados para informe v2 (~35 slides)
- process_data_expanded.py: extracción completa (top10 mercados, comarcas, campings, casas rurales, albergues, VUT por municipio, estancia media mensual)
- update_metrics.py: métricas adicionales
- build_report.py: script de construcción del informe ampliado (1068 líneas)
- metrics_dival.json: actualizado con oferta completa (565 hoteles, 7.949 VUTs, 48 campings, 369 casas rurales, 49 albergues)
- unpacked/ y unpacked_new/: plantilla desempaquetada lista para editar

Informe v2 en construcción: ~35 slides con análisis profundo por comarcas, comparativas 2024vs2025, top10 mercados, empleo y oferta turística completa.

Co-Authored-By: Claude Sonnet 4.6 <noreply@anthropic.com>
</commit_message>
<xml_diff>
--- a/Informe_DIVAL_2025.pptx
+++ b/Informe_DIVAL_2025.pptx
@@ -2181,7 +2181,7 @@
                   <c:v>4 ESTRELLAS</c:v>
                 </c:pt>
                 <c:pt idx="5">
-                  <c:v/>
+                  <c:v>SIN CATEG.</c:v>
                 </c:pt>
                 <c:pt idx="6">
                   <c:v>5 ESTRELLAS</c:v>
@@ -15347,7 +15347,7 @@
                 <a:latin typeface="Montserrat" pitchFamily="2" charset="77"/>
                 <a:cs typeface="Times New Roman" panose="02020603050405020304" pitchFamily="18" charset="0"/>
               </a:rPr>
-              <a:t>La provincia de Valencia registró 7.098.741 turistas en 2025 (-10.1% respecto a 2024). El turismo internacional alcanzó 3.605.939 visitantes (++13.6%), consolidando la recuperación post-pandémica. El turismo nacional registró 3.492.802 viajeros.</a:t>
+              <a:t>La provincia de Valencia registró 7.098.741 turistas en 2025 (-10.1% respecto a 2024). El turismo internacional alcanzó 3.605.939 visitantes (+13.6%), consolidando la recuperación post-pandémica. El turismo nacional registró 3.492.802 viajeros.</a:t>
             </a:r>
           </a:p>
         </p:txBody>

</xml_diff>